<commit_message>
Polish motion metadata and release handoff
</commit_message>
<xml_diff>
--- a/docs/Same-Sky-Hackathon-Deck.pptx
+++ b/docs/Same-Sky-Hackathon-Deck.pptx
@@ -2157,7 +2157,7 @@
                   <a:srgbClr val="F0EEE8"/>
                 </a:solidFill>
               </a:rPr>
-              <a:t>A private 30-second ritual that lets one person at the festival send presence—not content—to one person anywhere.</a:t>
+              <a:t>Livestreams transmit video. Same Sky transmits presence—one private ritual between someone at the festival and someone anywhere.</a:t>
             </a:r>
           </a:p>
         </p:txBody>
@@ -2743,7 +2743,7 @@
                   <a:srgbClr val="F0EEE8"/>
                 </a:solidFill>
               </a:rPr>
-              <a:t>The stream carries the show. It still leaves someone out.</a:t>
+              <a:t>The stream carries every pixel. It still leaves someone out.</a:t>
             </a:r>
           </a:p>
         </p:txBody>
@@ -3284,7 +3284,7 @@
                   <a:srgbClr val="F0EEE8"/>
                 </a:solidFill>
               </a:rPr>
-              <a:t>Thirty seconds. One private bridge.</a:t>
+              <a:t>Thirty seconds. One person. One pulse.</a:t>
             </a:r>
           </a:p>
         </p:txBody>

</xml_diff>